<commit_message>
Intial add MCP & AWS
</commit_message>
<xml_diff>
--- a/Output/LLM_report.pptx
+++ b/Output/LLM_report.pptx
@@ -12,8 +12,6 @@
     <p:sldId id="260" r:id="rId11"/>
     <p:sldId id="261" r:id="rId12"/>
     <p:sldId id="262" r:id="rId13"/>
-    <p:sldId id="263" r:id="rId14"/>
-    <p:sldId id="264" r:id="rId15"/>
   </p:sldIdLst>
   <p:sldSz cx="9144000" cy="6858000" type="screen4x3"/>
   <p:notesSz cx="6858000" cy="9144000"/>
@@ -3112,7 +3110,7 @@
           <a:lstStyle/>
           <a:p>
             <a:r>
-              <a:t>Overview of the RAG Q&amp;A System</a:t>
+              <a:t>Professional Profile &amp; Contact</a:t>
             </a:r>
           </a:p>
         </p:txBody>
@@ -3133,26 +3131,58 @@
           <a:lstStyle/>
           <a:p>
             <a:pPr>
-              <a:defRPr sz="2000"/>
-            </a:pPr>
-            <a:r>
-              <a:t>The RAG Q&amp;A System combines vector search, LLM generation, and a user‑friendly interface.</a:t>
+              <a:defRPr sz="1800"/>
+            </a:pPr>
+            <a:r>
+              <a:t>Name: Po Han Cheng</a:t>
             </a:r>
           </a:p>
           <a:p>
             <a:pPr>
-              <a:defRPr sz="2000"/>
-            </a:pPr>
-            <a:r>
-              <a:t>It supports multiple file types, dynamic knowledge‑base creation, and flexible retrieval strategies.</a:t>
+              <a:defRPr sz="1800"/>
+            </a:pPr>
+            <a:r>
+              <a:t>Status: Master’s Student, NYCU</a:t>
             </a:r>
           </a:p>
           <a:p>
             <a:pPr>
-              <a:defRPr sz="2000"/>
-            </a:pPr>
-            <a:r>
-              <a:t>The report outlines the workflow, technical choices, and UI improvements.</a:t>
+              <a:defRPr sz="1800"/>
+            </a:pPr>
+            <a:r>
+              <a:t>College: School of Computer Science</a:t>
+            </a:r>
+          </a:p>
+          <a:p>
+            <a:pPr>
+              <a:defRPr sz="1800"/>
+            </a:pPr>
+            <a:r>
+              <a:t>GitHub: https://github.com/po-han-cheng</a:t>
+            </a:r>
+          </a:p>
+          <a:p>
+            <a:pPr>
+              <a:defRPr sz="1800"/>
+            </a:pPr>
+            <a:r>
+              <a:t>Email: po.han.cheng@example.com</a:t>
+            </a:r>
+          </a:p>
+          <a:p>
+            <a:pPr>
+              <a:defRPr sz="1800"/>
+            </a:pPr>
+            <a:r>
+              <a:t>Phone: +1-555-123-4567</a:t>
+            </a:r>
+          </a:p>
+          <a:p>
+            <a:pPr>
+              <a:defRPr sz="1800"/>
+            </a:pPr>
+            <a:r>
+              <a:t>LinkedIn: https://linkedin.com/in/po-han-cheng</a:t>
             </a:r>
           </a:p>
         </p:txBody>
@@ -3191,7 +3221,7 @@
           <a:lstStyle/>
           <a:p>
             <a:r>
-              <a:t>End‑to‑End Usage Flow</a:t>
+              <a:t>Technical Highlights</a:t>
             </a:r>
           </a:p>
         </p:txBody>
@@ -3212,34 +3242,68 @@
           <a:lstStyle/>
           <a:p>
             <a:pPr>
-              <a:defRPr sz="2000"/>
-            </a:pPr>
-            <a:r>
-              <a:t>1. Knowledge‑base creation page – select or create DB, upload files, choose image‑embedding model.</a:t>
+              <a:defRPr sz="1800"/>
+            </a:pPr>
+            <a:r>
+              <a:t>Flagship GPU Subsystem:</a:t>
             </a:r>
           </a:p>
           <a:p>
             <a:pPr>
-              <a:defRPr sz="2000"/>
-            </a:pPr>
-            <a:r>
-              <a:t>2. Files are chunked, embedded via Ollama, stored in FAISS.</a:t>
+              <a:defRPr sz="1800"/>
+            </a:pPr>
+            <a:r>
+              <a:t>- C++ GPU subsystem with shared‑memory IPC, lock‑free ring buffers, DMA texture transfer</a:t>
             </a:r>
           </a:p>
           <a:p>
             <a:pPr>
-              <a:defRPr sz="2000"/>
-            </a:pPr>
-            <a:r>
-              <a:t>3. Q&amp;A interface – pick DB, set LLM params, enter question.</a:t>
+              <a:defRPr sz="1800"/>
+            </a:pPr>
+            <a:r>
+              <a:t>- ARM64 assembly optimizations, watchdog for thermal &amp; deadlock recovery</a:t>
             </a:r>
           </a:p>
           <a:p>
             <a:pPr>
-              <a:defRPr sz="2000"/>
-            </a:pPr>
-            <a:r>
-              <a:t>4. System retrieves relevant chunks, calls LLM, returns answer + source passages.</a:t>
+              <a:defRPr sz="1800"/>
+            </a:pPr>
+            <a:r>
+              <a:t>- PID Control Algorithm for performance tuning</a:t>
+            </a:r>
+          </a:p>
+          <a:p>
+            <a:pPr>
+              <a:defRPr sz="1800"/>
+            </a:pPr>
+          </a:p>
+          <a:p>
+            <a:pPr>
+              <a:defRPr sz="1800"/>
+            </a:pPr>
+            <a:r>
+              <a:t>Technologies:</a:t>
+            </a:r>
+          </a:p>
+          <a:p>
+            <a:pPr>
+              <a:defRPr sz="1800"/>
+            </a:pPr>
+            <a:r>
+              <a:t>- C++, ARM64 Assembly, POSIX IPC, Linux/Unix, PID Control</a:t>
+            </a:r>
+          </a:p>
+          <a:p>
+            <a:pPr>
+              <a:defRPr sz="1800"/>
+            </a:pPr>
+          </a:p>
+          <a:p>
+            <a:pPr>
+              <a:defRPr sz="1800"/>
+            </a:pPr>
+            <a:r>
+              <a:t>Demo Video: Available on GitHub repository</a:t>
             </a:r>
           </a:p>
         </p:txBody>
@@ -3278,7 +3342,7 @@
           <a:lstStyle/>
           <a:p>
             <a:r>
-              <a:t>Retrieval Strategies</a:t>
+              <a:t>Side Projects &amp; Certifications</a:t>
             </a:r>
           </a:p>
         </p:txBody>
@@ -3299,26 +3363,87 @@
           <a:lstStyle/>
           <a:p>
             <a:pPr>
-              <a:defRPr sz="2000"/>
-            </a:pPr>
-            <a:r>
-              <a:t>MMR – promotes diversity by penalizing similar chunks.</a:t>
+              <a:defRPr sz="1800"/>
+            </a:pPr>
+            <a:r>
+              <a:t>Side Projects:</a:t>
             </a:r>
           </a:p>
           <a:p>
             <a:pPr>
-              <a:defRPr sz="2000"/>
-            </a:pPr>
-            <a:r>
-              <a:t>Reranking – post‑process similarity results with a dedicated model for higher relevance.</a:t>
+              <a:defRPr sz="1800"/>
+            </a:pPr>
+            <a:r>
+              <a:t>- vGPU‑Sim: Multi‑tenant GPU architecture simulator</a:t>
             </a:r>
           </a:p>
           <a:p>
             <a:pPr>
-              <a:defRPr sz="2000"/>
-            </a:pPr>
-            <a:r>
-              <a:t>Custom RAG – fetch top chunk, feed entire document to LLM for completeness, useful with many files.</a:t>
+              <a:defRPr sz="1800"/>
+            </a:pPr>
+            <a:r>
+              <a:t>- AI‑Powered E‑commerce Recommendation Platform</a:t>
+            </a:r>
+          </a:p>
+          <a:p>
+            <a:pPr>
+              <a:defRPr sz="1800"/>
+            </a:pPr>
+            <a:r>
+              <a:t>  • Recommendation algorithm, shopping cart, CI/CD pipeline (DVC, Airflow, GitHub Actions)</a:t>
+            </a:r>
+          </a:p>
+          <a:p>
+            <a:pPr>
+              <a:defRPr sz="1800"/>
+            </a:pPr>
+            <a:r>
+              <a:t>  • 11× inference speedup, 0.13 NDCG</a:t>
+            </a:r>
+          </a:p>
+          <a:p>
+            <a:pPr>
+              <a:defRPr sz="1800"/>
+            </a:pPr>
+            <a:r>
+              <a:t>  • Technologies: MLOps, MLflow, Airflow, DVC, CI/CD, Docker, Git, FastAPI, Transformer, GQA, KV Caching</a:t>
+            </a:r>
+          </a:p>
+          <a:p>
+            <a:pPr>
+              <a:defRPr sz="1800"/>
+            </a:pPr>
+            <a:r>
+              <a:t>  • Demo Video: Link</a:t>
+            </a:r>
+          </a:p>
+          <a:p>
+            <a:pPr>
+              <a:defRPr sz="1800"/>
+            </a:pPr>
+          </a:p>
+          <a:p>
+            <a:pPr>
+              <a:defRPr sz="1800"/>
+            </a:pPr>
+            <a:r>
+              <a:t>Certifications:</a:t>
+            </a:r>
+          </a:p>
+          <a:p>
+            <a:pPr>
+              <a:defRPr sz="1800"/>
+            </a:pPr>
+            <a:r>
+              <a:t>- Google Cloud Certificate of Completion</a:t>
+            </a:r>
+          </a:p>
+          <a:p>
+            <a:pPr>
+              <a:defRPr sz="1800"/>
+            </a:pPr>
+            <a:r>
+              <a:t>- AWS Certified AI Practitioner</a:t>
             </a:r>
           </a:p>
         </p:txBody>
@@ -3357,7 +3482,7 @@
           <a:lstStyle/>
           <a:p>
             <a:r>
-              <a:t>UI Enhancements &amp; Database Management</a:t>
+              <a:t>Work Experience &amp; Master’s Thesis</a:t>
             </a:r>
           </a:p>
         </p:txBody>
@@ -3378,34 +3503,95 @@
           <a:lstStyle/>
           <a:p>
             <a:pPr>
-              <a:defRPr sz="2000"/>
-            </a:pPr>
-            <a:r>
-              <a:t>• Separate knowledge‑base creation from Q&amp;A.</a:t>
+              <a:defRPr sz="1800"/>
+            </a:pPr>
+            <a:r>
+              <a:t>AI Application Development Intern, ESMT (Jul–Aug 2025)</a:t>
             </a:r>
           </a:p>
           <a:p>
             <a:pPr>
-              <a:defRPr sz="2000"/>
-            </a:pPr>
-            <a:r>
-              <a:t>• Persistent DB list with metadata (chunk_size, overlap).</a:t>
+              <a:defRPr sz="1800"/>
+            </a:pPr>
+            <a:r>
+              <a:t>- Platforms: GCP Vertex AI, AWS SageMaker, Bedrock, Amazon Q</a:t>
             </a:r>
           </a:p>
           <a:p>
             <a:pPr>
-              <a:defRPr sz="2000"/>
-            </a:pPr>
-            <a:r>
-              <a:t>• Add/remove files on the fly.</a:t>
+              <a:defRPr sz="1800"/>
+            </a:pPr>
+            <a:r>
+              <a:t>- Projects:</a:t>
             </a:r>
           </a:p>
           <a:p>
             <a:pPr>
-              <a:defRPr sz="2000"/>
-            </a:pPr>
-            <a:r>
-              <a:t>• Retrieval mode selector (Basic, Reranking, MMR, Custom).</a:t>
+              <a:defRPr sz="1800"/>
+            </a:pPr>
+            <a:r>
+              <a:t>  • Multimodal Retrieval‑Augmented Generation (RAG) Q&amp;A system – 0.82 faithfulness, 0.71 relevancy</a:t>
+            </a:r>
+          </a:p>
+          <a:p>
+            <a:pPr>
+              <a:defRPr sz="1800"/>
+            </a:pPr>
+            <a:r>
+              <a:t>  • Custom RAG for large‑scale documents</a:t>
+            </a:r>
+          </a:p>
+          <a:p>
+            <a:pPr>
+              <a:defRPr sz="1800"/>
+            </a:pPr>
+            <a:r>
+              <a:t>  • AI agent generating PowerPoint presentations from uploaded files</a:t>
+            </a:r>
+          </a:p>
+          <a:p>
+            <a:pPr>
+              <a:defRPr sz="1800"/>
+            </a:pPr>
+            <a:r>
+              <a:t>  • Demo videos available</a:t>
+            </a:r>
+          </a:p>
+          <a:p>
+            <a:pPr>
+              <a:defRPr sz="1800"/>
+            </a:pPr>
+          </a:p>
+          <a:p>
+            <a:pPr>
+              <a:defRPr sz="1800"/>
+            </a:pPr>
+            <a:r>
+              <a:t>Master’s Thesis: "AI Security / Prompt Injection Defense / AST / Perplexity / Prompt Engineering / Code LLM"</a:t>
+            </a:r>
+          </a:p>
+          <a:p>
+            <a:pPr>
+              <a:defRPr sz="1800"/>
+            </a:pPr>
+            <a:r>
+              <a:t>- Dual‑Guardrail system detecting malicious prompts via logits &amp; Min‑K% token anomaly</a:t>
+            </a:r>
+          </a:p>
+          <a:p>
+            <a:pPr>
+              <a:defRPr sz="1800"/>
+            </a:pPr>
+            <a:r>
+              <a:t>- Results: 0.938 F1, 7 % false‑positive, reduced CodeBERT attack success from 99.3 % to 11.1 % (vs 81.7 % baseline)</a:t>
+            </a:r>
+          </a:p>
+          <a:p>
+            <a:pPr>
+              <a:defRPr sz="1800"/>
+            </a:pPr>
+            <a:r>
+              <a:t>- Subtitle: "Defending External Code against Indirect Prompt Injection"</a:t>
             </a:r>
           </a:p>
         </p:txBody>
@@ -3444,7 +3630,7 @@
           <a:lstStyle/>
           <a:p>
             <a:r>
-              <a:t>File Upload Processor &amp; Document Conversion</a:t>
+              <a:t>Research Internship &amp; Impact</a:t>
             </a:r>
           </a:p>
         </p:txBody>
@@ -3465,26 +3651,63 @@
           <a:lstStyle/>
           <a:p>
             <a:pPr>
-              <a:defRPr sz="2000"/>
-            </a:pPr>
-            <a:r>
-              <a:t>Upload_file module handles PDFs, images, Word, PPT, audio, video, text.</a:t>
+              <a:defRPr sz="1800"/>
+            </a:pPr>
+            <a:r>
+              <a:t>AI Security Researcher Intern, Hon Hai (Feb–Jun 2025)</a:t>
             </a:r>
           </a:p>
           <a:p>
             <a:pPr>
-              <a:defRPr sz="2000"/>
-            </a:pPr>
-            <a:r>
-              <a:t>OCR via Tesseract, image captions via Ollama multimodal, Whisper for speech.</a:t>
+              <a:defRPr sz="1800"/>
+            </a:pPr>
+            <a:r>
+              <a:t>- Focus: Python, AI security, data poisoning, perplexity</a:t>
             </a:r>
           </a:p>
           <a:p>
             <a:pPr>
-              <a:defRPr sz="2000"/>
-            </a:pPr>
-            <a:r>
-              <a:t>All content wrapped in LangChain Document with metadata for source tracking.</a:t>
+              <a:defRPr sz="1800"/>
+            </a:pPr>
+            <a:r>
+              <a:t>- Achievement: 0.88 F1 detecting Code LLM training data poisoning using DePA</a:t>
+            </a:r>
+          </a:p>
+          <a:p>
+            <a:pPr>
+              <a:defRPr sz="1800"/>
+            </a:pPr>
+          </a:p>
+          <a:p>
+            <a:pPr>
+              <a:defRPr sz="1800"/>
+            </a:pPr>
+            <a:r>
+              <a:t>Overall Impact:</a:t>
+            </a:r>
+          </a:p>
+          <a:p>
+            <a:pPr>
+              <a:defRPr sz="1800"/>
+            </a:pPr>
+            <a:r>
+              <a:t>- Demonstrated expertise in GPU systems, MLOps, and AI security</a:t>
+            </a:r>
+          </a:p>
+          <a:p>
+            <a:pPr>
+              <a:defRPr sz="1800"/>
+            </a:pPr>
+            <a:r>
+              <a:t>- Delivered measurable performance gains and robust defense mechanisms</a:t>
+            </a:r>
+          </a:p>
+          <a:p>
+            <a:pPr>
+              <a:defRPr sz="1800"/>
+            </a:pPr>
+            <a:r>
+              <a:t>- Provided demo videos and certifications to substantiate claims</a:t>
             </a:r>
           </a:p>
         </p:txBody>
@@ -3523,212 +3746,6 @@
           <a:lstStyle/>
           <a:p>
             <a:r>
-              <a:t>Streamlit App Architecture &amp; Modules</a:t>
-            </a:r>
-          </a:p>
-        </p:txBody>
-      </p:sp>
-      <p:sp>
-        <p:nvSpPr>
-          <p:cNvPr id="3" name="Content Placeholder 2"/>
-          <p:cNvSpPr>
-            <a:spLocks noGrp="1"/>
-          </p:cNvSpPr>
-          <p:nvPr>
-            <p:ph idx="1"/>
-          </p:nvPr>
-        </p:nvSpPr>
-        <p:spPr/>
-        <p:txBody>
-          <a:bodyPr/>
-          <a:lstStyle/>
-          <a:p>
-            <a:pPr>
-              <a:defRPr sz="2000"/>
-            </a:pPr>
-            <a:r>
-              <a:t>• app.py – page config, sidebar navigation.</a:t>
-            </a:r>
-          </a:p>
-          <a:p>
-            <a:pPr>
-              <a:defRPr sz="2000"/>
-            </a:pPr>
-            <a:r>
-              <a:t>• pages/Build_Knowledge_Base.py – DB management.</a:t>
-            </a:r>
-          </a:p>
-          <a:p>
-            <a:pPr>
-              <a:defRPr sz="2000"/>
-            </a:pPr>
-            <a:r>
-              <a:t>• pages/Answering_Interface.py – query interface.</a:t>
-            </a:r>
-          </a:p>
-          <a:p>
-            <a:pPr>
-              <a:defRPr sz="2000"/>
-            </a:pPr>
-            <a:r>
-              <a:t>• RAG_Embedding.py – vector store CRUD.</a:t>
-            </a:r>
-          </a:p>
-          <a:p>
-            <a:pPr>
-              <a:defRPr sz="2000"/>
-            </a:pPr>
-            <a:r>
-              <a:t>• RAG_LLM_Generator.py – prompt construction &amp; LLM call.</a:t>
-            </a:r>
-          </a:p>
-          <a:p>
-            <a:pPr>
-              <a:defRPr sz="2000"/>
-            </a:pPr>
-            <a:r>
-              <a:t>• reranking.py – chunk reranking.</a:t>
-            </a:r>
-          </a:p>
-          <a:p>
-            <a:pPr>
-              <a:defRPr sz="2000"/>
-            </a:pPr>
-            <a:r>
-              <a:t>• utils.py, config.py – helpers and defaults.</a:t>
-            </a:r>
-          </a:p>
-        </p:txBody>
-      </p:sp>
-    </p:spTree>
-  </p:cSld>
-  <p:clrMapOvr>
-    <a:masterClrMapping/>
-  </p:clrMapOvr>
-</p:sld>
-</file>
-
-<file path=ppt/slides/slide7.xml><?xml version="1.0" encoding="utf-8"?>
-<p:sld xmlns:a="http://schemas.openxmlformats.org/drawingml/2006/main" xmlns:p="http://schemas.openxmlformats.org/presentationml/2006/main" xmlns:r="http://schemas.openxmlformats.org/officeDocument/2006/relationships">
-  <p:cSld>
-    <p:spTree>
-      <p:nvGrpSpPr>
-        <p:cNvPr id="1" name=""/>
-        <p:cNvGrpSpPr/>
-        <p:nvPr/>
-      </p:nvGrpSpPr>
-      <p:grpSpPr/>
-      <p:sp>
-        <p:nvSpPr>
-          <p:cNvPr id="2" name="Title 1"/>
-          <p:cNvSpPr>
-            <a:spLocks noGrp="1"/>
-          </p:cNvSpPr>
-          <p:nvPr>
-            <p:ph type="title"/>
-          </p:nvPr>
-        </p:nvSpPr>
-        <p:spPr/>
-        <p:txBody>
-          <a:bodyPr/>
-          <a:lstStyle/>
-          <a:p>
-            <a:r>
-              <a:t>Core Features &amp; Benefits</a:t>
-            </a:r>
-          </a:p>
-        </p:txBody>
-      </p:sp>
-      <p:sp>
-        <p:nvSpPr>
-          <p:cNvPr id="3" name="Content Placeholder 2"/>
-          <p:cNvSpPr>
-            <a:spLocks noGrp="1"/>
-          </p:cNvSpPr>
-          <p:nvPr>
-            <p:ph idx="1"/>
-          </p:nvPr>
-        </p:nvSpPr>
-        <p:spPr/>
-        <p:txBody>
-          <a:bodyPr/>
-          <a:lstStyle/>
-          <a:p>
-            <a:pPr>
-              <a:defRPr sz="2000"/>
-            </a:pPr>
-            <a:r>
-              <a:t>• Multi‑format ingestion and dynamic DB updates.</a:t>
-            </a:r>
-          </a:p>
-          <a:p>
-            <a:pPr>
-              <a:defRPr sz="2000"/>
-            </a:pPr>
-            <a:r>
-              <a:t>• Fast FAISS retrieval with Ollama embeddings.</a:t>
-            </a:r>
-          </a:p>
-          <a:p>
-            <a:pPr>
-              <a:defRPr sz="2000"/>
-            </a:pPr>
-            <a:r>
-              <a:t>• Flexible retrieval strategies for accuracy &amp; diversity.</a:t>
-            </a:r>
-          </a:p>
-          <a:p>
-            <a:pPr>
-              <a:defRPr sz="2000"/>
-            </a:pPr>
-            <a:r>
-              <a:t>• Transparent answers with source passages and chain of thought.</a:t>
-            </a:r>
-          </a:p>
-          <a:p>
-            <a:pPr>
-              <a:defRPr sz="2000"/>
-            </a:pPr>
-            <a:r>
-              <a:t>• User‑controlled LLM parameters via UI.</a:t>
-            </a:r>
-          </a:p>
-        </p:txBody>
-      </p:sp>
-    </p:spTree>
-  </p:cSld>
-  <p:clrMapOvr>
-    <a:masterClrMapping/>
-  </p:clrMapOvr>
-</p:sld>
-</file>
-
-<file path=ppt/slides/slide8.xml><?xml version="1.0" encoding="utf-8"?>
-<p:sld xmlns:a="http://schemas.openxmlformats.org/drawingml/2006/main" xmlns:p="http://schemas.openxmlformats.org/presentationml/2006/main" xmlns:r="http://schemas.openxmlformats.org/officeDocument/2006/relationships">
-  <p:cSld>
-    <p:spTree>
-      <p:nvGrpSpPr>
-        <p:cNvPr id="1" name=""/>
-        <p:cNvGrpSpPr/>
-        <p:nvPr/>
-      </p:nvGrpSpPr>
-      <p:grpSpPr/>
-      <p:sp>
-        <p:nvSpPr>
-          <p:cNvPr id="2" name="Title 1"/>
-          <p:cNvSpPr>
-            <a:spLocks noGrp="1"/>
-          </p:cNvSpPr>
-          <p:nvPr>
-            <p:ph type="title"/>
-          </p:nvPr>
-        </p:nvSpPr>
-        <p:spPr/>
-        <p:txBody>
-          <a:bodyPr/>
-          <a:lstStyle/>
-          <a:p>
-            <a:r>
               <a:t>清單圖</a:t>
             </a:r>
           </a:p>
@@ -3743,7 +3760,7 @@
         <p:spPr>
           <a:xfrm>
             <a:off x="274320" y="1828800"/>
-            <a:ext cx="2743200" cy="914400"/>
+            <a:ext cx="2011680" cy="914400"/>
           </a:xfrm>
           <a:prstGeom prst="roundRect">
             <a:avLst/>
@@ -3779,7 +3796,7 @@
                 </a:solidFill>
                 <a:latin typeface="Segoe UI Emoji"/>
               </a:rPr>
-              <a:t>📚
+              <a:t>👤
 </a:t>
             </a:r>
           </a:p>
@@ -3794,7 +3811,7 @@
         <p:spPr>
           <a:xfrm>
             <a:off x="274320" y="2743200"/>
-            <a:ext cx="2743200" cy="1828800"/>
+            <a:ext cx="2011680" cy="1828800"/>
           </a:xfrm>
           <a:prstGeom prst="roundRect">
             <a:avLst/>
@@ -3837,7 +3854,7 @@
                   <a:srgbClr val="000000"/>
                 </a:solidFill>
               </a:rPr>
-              <a:t>知識庫建立
+              <a:t>個人簡介
 </a:t>
             </a:r>
             <a:r>
@@ -3846,7 +3863,7 @@
                   <a:srgbClr val="000000"/>
                 </a:solidFill>
               </a:rPr>
-              <a:t>選擇/建立 DB、上傳檔案</a:t>
+              <a:t>姓名、學歷、聯絡</a:t>
             </a:r>
           </a:p>
         </p:txBody>
@@ -3859,8 +3876,8 @@
         </p:nvSpPr>
         <p:spPr>
           <a:xfrm>
-            <a:off x="3200400" y="1828800"/>
-            <a:ext cx="2743200" cy="914400"/>
+            <a:off x="2468880" y="1828800"/>
+            <a:ext cx="2011680" cy="914400"/>
           </a:xfrm>
           <a:prstGeom prst="roundRect">
             <a:avLst/>
@@ -3896,7 +3913,7 @@
                 </a:solidFill>
                 <a:latin typeface="Segoe UI Emoji"/>
               </a:rPr>
-              <a:t>🤖
+              <a:t>🛠️
 </a:t>
             </a:r>
           </a:p>
@@ -3910,8 +3927,8 @@
         </p:nvSpPr>
         <p:spPr>
           <a:xfrm>
-            <a:off x="3200400" y="2743200"/>
-            <a:ext cx="2743200" cy="1828800"/>
+            <a:off x="2468880" y="2743200"/>
+            <a:ext cx="2011680" cy="1828800"/>
           </a:xfrm>
           <a:prstGeom prst="roundRect">
             <a:avLst/>
@@ -3954,7 +3971,7 @@
                   <a:srgbClr val="000000"/>
                 </a:solidFill>
               </a:rPr>
-              <a:t>檢索與生成
+              <a:t>技術專長
 </a:t>
             </a:r>
             <a:r>
@@ -3963,7 +3980,7 @@
                   <a:srgbClr val="000000"/>
                 </a:solidFill>
               </a:rPr>
-              <a:t>檢索相關片段、LLM 回答</a:t>
+              <a:t>GPU、C++、ARM64</a:t>
             </a:r>
           </a:p>
         </p:txBody>
@@ -3976,8 +3993,8 @@
         </p:nvSpPr>
         <p:spPr>
           <a:xfrm>
-            <a:off x="6126480" y="1828800"/>
-            <a:ext cx="2743200" cy="914400"/>
+            <a:off x="4663440" y="1828800"/>
+            <a:ext cx="2011680" cy="914400"/>
           </a:xfrm>
           <a:prstGeom prst="roundRect">
             <a:avLst/>
@@ -4013,7 +4030,7 @@
                 </a:solidFill>
                 <a:latin typeface="Segoe UI Emoji"/>
               </a:rPr>
-              <a:t>🛠️
+              <a:t>📁
 </a:t>
             </a:r>
           </a:p>
@@ -4027,8 +4044,8 @@
         </p:nvSpPr>
         <p:spPr>
           <a:xfrm>
-            <a:off x="6126480" y="2743200"/>
-            <a:ext cx="2743200" cy="1828800"/>
+            <a:off x="4663440" y="2743200"/>
+            <a:ext cx="2011680" cy="1828800"/>
           </a:xfrm>
           <a:prstGeom prst="roundRect">
             <a:avLst/>
@@ -4071,7 +4088,7 @@
                   <a:srgbClr val="000000"/>
                 </a:solidFill>
               </a:rPr>
-              <a:t>系統架構與功能
+              <a:t>專案與證照
 </a:t>
             </a:r>
             <a:r>
@@ -4080,7 +4097,124 @@
                   <a:srgbClr val="000000"/>
                 </a:solidFill>
               </a:rPr>
-              <a:t>模組化設計、UI 優化</a:t>
+              <a:t>vGPU‑Sim、AI 平台</a:t>
+            </a:r>
+          </a:p>
+        </p:txBody>
+      </p:sp>
+      <p:sp>
+        <p:nvSpPr>
+          <p:cNvPr id="9" name="Rounded Rectangle 8"/>
+          <p:cNvSpPr/>
+          <p:nvPr/>
+        </p:nvSpPr>
+        <p:spPr>
+          <a:xfrm>
+            <a:off x="6858000" y="1828800"/>
+            <a:ext cx="2011680" cy="914400"/>
+          </a:xfrm>
+          <a:prstGeom prst="roundRect">
+            <a:avLst/>
+          </a:prstGeom>
+          <a:noFill/>
+          <a:ln>
+            <a:noFill/>
+          </a:ln>
+        </p:spPr>
+        <p:style>
+          <a:lnRef idx="1">
+            <a:schemeClr val="accent1"/>
+          </a:lnRef>
+          <a:fillRef idx="3">
+            <a:schemeClr val="accent1"/>
+          </a:fillRef>
+          <a:effectRef idx="2">
+            <a:schemeClr val="accent1"/>
+          </a:effectRef>
+          <a:fontRef idx="minor">
+            <a:schemeClr val="lt1"/>
+          </a:fontRef>
+        </p:style>
+        <p:txBody>
+          <a:bodyPr rtlCol="0" anchor="ctr"/>
+          <a:lstStyle/>
+          <a:p>
+            <a:pPr algn="ctr"/>
+            <a:r>
+              <a:rPr sz="3000">
+                <a:solidFill>
+                  <a:srgbClr val="0066CC"/>
+                </a:solidFill>
+                <a:latin typeface="Segoe UI Emoji"/>
+              </a:rPr>
+              <a:t>🏢
+</a:t>
+            </a:r>
+          </a:p>
+        </p:txBody>
+      </p:sp>
+      <p:sp>
+        <p:nvSpPr>
+          <p:cNvPr id="10" name="Rounded Rectangle 9"/>
+          <p:cNvSpPr/>
+          <p:nvPr/>
+        </p:nvSpPr>
+        <p:spPr>
+          <a:xfrm>
+            <a:off x="6858000" y="2743200"/>
+            <a:ext cx="2011680" cy="1828800"/>
+          </a:xfrm>
+          <a:prstGeom prst="roundRect">
+            <a:avLst/>
+          </a:prstGeom>
+          <a:solidFill>
+            <a:srgbClr val="DAEBF7"/>
+          </a:solidFill>
+          <a:ln>
+            <a:solidFill>
+              <a:srgbClr val="000000"/>
+            </a:solidFill>
+          </a:ln>
+        </p:spPr>
+        <p:style>
+          <a:lnRef idx="1">
+            <a:schemeClr val="accent1"/>
+          </a:lnRef>
+          <a:fillRef idx="3">
+            <a:schemeClr val="accent1"/>
+          </a:fillRef>
+          <a:effectRef idx="2">
+            <a:schemeClr val="accent1"/>
+          </a:effectRef>
+          <a:fontRef idx="minor">
+            <a:schemeClr val="lt1"/>
+          </a:fontRef>
+        </p:style>
+        <p:txBody>
+          <a:bodyPr rtlCol="0" anchor="ctr"/>
+          <a:lstStyle/>
+          <a:p>
+            <a:pPr algn="ctr">
+              <a:spcAft>
+                <a:spcPts val="400"/>
+              </a:spcAft>
+            </a:pPr>
+            <a:r>
+              <a:rPr sz="1300" b="1">
+                <a:solidFill>
+                  <a:srgbClr val="000000"/>
+                </a:solidFill>
+              </a:rPr>
+              <a:t>工作經驗與論文
+</a:t>
+            </a:r>
+            <a:r>
+              <a:rPr sz="1000">
+                <a:solidFill>
+                  <a:srgbClr val="000000"/>
+                </a:solidFill>
+              </a:rPr>
+              <a:t>實習、論文、影響</a:t>
             </a:r>
           </a:p>
         </p:txBody>
@@ -4093,7 +4227,7 @@
 </p:sld>
 </file>
 
-<file path=ppt/slides/slide9.xml><?xml version="1.0" encoding="utf-8"?>
+<file path=ppt/slides/slide7.xml><?xml version="1.0" encoding="utf-8"?>
 <p:sld xmlns:a="http://schemas.openxmlformats.org/drawingml/2006/main" xmlns:p="http://schemas.openxmlformats.org/presentationml/2006/main" xmlns:r="http://schemas.openxmlformats.org/officeDocument/2006/relationships">
   <p:cSld>
     <p:spTree>
@@ -4132,7 +4266,7 @@
         </p:nvSpPr>
         <p:spPr>
           <a:xfrm>
-            <a:off x="3657600" y="1417320"/>
+            <a:off x="3657600" y="1325880"/>
             <a:ext cx="1828800" cy="1645920"/>
           </a:xfrm>
           <a:prstGeom prst="ellipse">
@@ -4173,7 +4307,7 @@
                 </a:solidFill>
                 <a:latin typeface="Segoe UI Emoji"/>
               </a:rPr>
-              <a:t>📚
+              <a:t>👤
 </a:t>
             </a:r>
             <a:r>
@@ -4182,7 +4316,7 @@
                   <a:srgbClr val="000000"/>
                 </a:solidFill>
               </a:rPr>
-              <a:t>知識庫建立
+              <a:t>個人簡介
 </a:t>
             </a:r>
           </a:p>
@@ -4196,7 +4330,7 @@
         </p:nvSpPr>
         <p:spPr>
           <a:xfrm>
-            <a:off x="5083008" y="3886200"/>
+            <a:off x="5394960" y="3063240"/>
             <a:ext cx="1828800" cy="1645920"/>
           </a:xfrm>
           <a:prstGeom prst="ellipse">
@@ -4237,7 +4371,7 @@
                 </a:solidFill>
                 <a:latin typeface="Segoe UI Emoji"/>
               </a:rPr>
-              <a:t>🤖
+              <a:t>🛠️
 </a:t>
             </a:r>
             <a:r>
@@ -4246,7 +4380,7 @@
                   <a:srgbClr val="000000"/>
                 </a:solidFill>
               </a:rPr>
-              <a:t>檢索與生成
+              <a:t>技術專長
 </a:t>
             </a:r>
           </a:p>
@@ -4260,7 +4394,7 @@
         </p:nvSpPr>
         <p:spPr>
           <a:xfrm>
-            <a:off x="2232191" y="3886200"/>
+            <a:off x="3657600" y="4800600"/>
             <a:ext cx="1828800" cy="1645920"/>
           </a:xfrm>
           <a:prstGeom prst="ellipse">
@@ -4301,7 +4435,7 @@
                 </a:solidFill>
                 <a:latin typeface="Segoe UI Emoji"/>
               </a:rPr>
-              <a:t>🛠️
+              <a:t>📁
 </a:t>
             </a:r>
             <a:r>
@@ -4310,7 +4444,71 @@
                   <a:srgbClr val="000000"/>
                 </a:solidFill>
               </a:rPr>
-              <a:t>系統架構與功能
+              <a:t>專案與證照
+</a:t>
+            </a:r>
+          </a:p>
+        </p:txBody>
+      </p:sp>
+      <p:sp>
+        <p:nvSpPr>
+          <p:cNvPr id="6" name="Oval 5"/>
+          <p:cNvSpPr/>
+          <p:nvPr/>
+        </p:nvSpPr>
+        <p:spPr>
+          <a:xfrm>
+            <a:off x="1920240" y="3063240"/>
+            <a:ext cx="1828800" cy="1645920"/>
+          </a:xfrm>
+          <a:prstGeom prst="ellipse">
+            <a:avLst/>
+          </a:prstGeom>
+          <a:solidFill>
+            <a:srgbClr val="DDEBF7"/>
+          </a:solidFill>
+          <a:ln>
+            <a:solidFill>
+              <a:srgbClr val="000000"/>
+            </a:solidFill>
+          </a:ln>
+        </p:spPr>
+        <p:style>
+          <a:lnRef idx="1">
+            <a:schemeClr val="accent1"/>
+          </a:lnRef>
+          <a:fillRef idx="3">
+            <a:schemeClr val="accent1"/>
+          </a:fillRef>
+          <a:effectRef idx="2">
+            <a:schemeClr val="accent1"/>
+          </a:effectRef>
+          <a:fontRef idx="minor">
+            <a:schemeClr val="lt1"/>
+          </a:fontRef>
+        </p:style>
+        <p:txBody>
+          <a:bodyPr rtlCol="0" anchor="ctr"/>
+          <a:lstStyle/>
+          <a:p>
+            <a:pPr algn="ctr"/>
+            <a:r>
+              <a:rPr sz="3000">
+                <a:solidFill>
+                  <a:srgbClr val="0066CC"/>
+                </a:solidFill>
+                <a:latin typeface="Segoe UI Emoji"/>
+              </a:rPr>
+              <a:t>🏢
+</a:t>
+            </a:r>
+            <a:r>
+              <a:rPr sz="1300" b="1">
+                <a:solidFill>
+                  <a:srgbClr val="000000"/>
+                </a:solidFill>
+              </a:rPr>
+              <a:t>工作經驗與論文
 </a:t>
             </a:r>
           </a:p>

</xml_diff>

<commit_message>
MCP & AWS successfully
</commit_message>
<xml_diff>
--- a/Output/LLM_report.pptx
+++ b/Output/LLM_report.pptx
@@ -3110,7 +3110,7 @@
           <a:lstStyle/>
           <a:p>
             <a:r>
-              <a:t>Professional Profile &amp; Contact</a:t>
+              <a:t>個人簡介</a:t>
             </a:r>
           </a:p>
         </p:txBody>
@@ -3134,7 +3134,7 @@
               <a:defRPr sz="1800"/>
             </a:pPr>
             <a:r>
-              <a:t>Name: Po Han Cheng</a:t>
+              <a:t>姓名：Po Han Cheng</a:t>
             </a:r>
           </a:p>
           <a:p>
@@ -3142,7 +3142,7 @@
               <a:defRPr sz="1800"/>
             </a:pPr>
             <a:r>
-              <a:t>Status: Master’s Student, NYCU</a:t>
+              <a:t>學位：國立陽明交通大學計算機科學學士</a:t>
             </a:r>
           </a:p>
           <a:p>
@@ -3150,7 +3150,7 @@
               <a:defRPr sz="1800"/>
             </a:pPr>
             <a:r>
-              <a:t>College: School of Computer Science</a:t>
+              <a:t>就讀年份：2022年至今</a:t>
             </a:r>
           </a:p>
           <a:p>
@@ -3158,31 +3158,7 @@
               <a:defRPr sz="1800"/>
             </a:pPr>
             <a:r>
-              <a:t>GitHub: https://github.com/po-han-cheng</a:t>
-            </a:r>
-          </a:p>
-          <a:p>
-            <a:pPr>
-              <a:defRPr sz="1800"/>
-            </a:pPr>
-            <a:r>
-              <a:t>Email: po.han.cheng@example.com</a:t>
-            </a:r>
-          </a:p>
-          <a:p>
-            <a:pPr>
-              <a:defRPr sz="1800"/>
-            </a:pPr>
-            <a:r>
-              <a:t>Phone: +1-555-123-4567</a:t>
-            </a:r>
-          </a:p>
-          <a:p>
-            <a:pPr>
-              <a:defRPr sz="1800"/>
-            </a:pPr>
-            <a:r>
-              <a:t>LinkedIn: https://linkedin.com/in/po-han-cheng</a:t>
+              <a:t>目標：展示專業背景、技術技能與研究成果</a:t>
             </a:r>
           </a:p>
         </p:txBody>
@@ -3221,7 +3197,7 @@
           <a:lstStyle/>
           <a:p>
             <a:r>
-              <a:t>Technical Highlights</a:t>
+              <a:t>技術能力</a:t>
             </a:r>
           </a:p>
         </p:txBody>
@@ -3245,7 +3221,7 @@
               <a:defRPr sz="1800"/>
             </a:pPr>
             <a:r>
-              <a:t>Flagship GPU Subsystem:</a:t>
+              <a:t>程式語言：C++、Python</a:t>
             </a:r>
           </a:p>
           <a:p>
@@ -3253,7 +3229,7 @@
               <a:defRPr sz="1800"/>
             </a:pPr>
             <a:r>
-              <a:t>- C++ GPU subsystem with shared‑memory IPC, lock‑free ring buffers, DMA texture transfer</a:t>
+              <a:t>專業技術：GPU計算、Linux系統、AI開發、安全技術</a:t>
             </a:r>
           </a:p>
           <a:p>
@@ -3261,7 +3237,7 @@
               <a:defRPr sz="1800"/>
             </a:pPr>
             <a:r>
-              <a:t>- ARM64 assembly optimizations, watchdog for thermal &amp; deadlock recovery</a:t>
+              <a:t>AI/ML知識：Transformer、GQA、KV快取、提示工程</a:t>
             </a:r>
           </a:p>
           <a:p>
@@ -3269,41 +3245,7 @@
               <a:defRPr sz="1800"/>
             </a:pPr>
             <a:r>
-              <a:t>- PID Control Algorithm for performance tuning</a:t>
-            </a:r>
-          </a:p>
-          <a:p>
-            <a:pPr>
-              <a:defRPr sz="1800"/>
-            </a:pPr>
-          </a:p>
-          <a:p>
-            <a:pPr>
-              <a:defRPr sz="1800"/>
-            </a:pPr>
-            <a:r>
-              <a:t>Technologies:</a:t>
-            </a:r>
-          </a:p>
-          <a:p>
-            <a:pPr>
-              <a:defRPr sz="1800"/>
-            </a:pPr>
-            <a:r>
-              <a:t>- C++, ARM64 Assembly, POSIX IPC, Linux/Unix, PID Control</a:t>
-            </a:r>
-          </a:p>
-          <a:p>
-            <a:pPr>
-              <a:defRPr sz="1800"/>
-            </a:pPr>
-          </a:p>
-          <a:p>
-            <a:pPr>
-              <a:defRPr sz="1800"/>
-            </a:pPr>
-            <a:r>
-              <a:t>Demo Video: Available on GitHub repository</a:t>
+              <a:t>工具使用：Git、Docker、FastAPI</a:t>
             </a:r>
           </a:p>
         </p:txBody>
@@ -3342,7 +3284,7 @@
           <a:lstStyle/>
           <a:p>
             <a:r>
-              <a:t>Side Projects &amp; Certifications</a:t>
+              <a:t>AI專業專長</a:t>
             </a:r>
           </a:p>
         </p:txBody>
@@ -3366,7 +3308,7 @@
               <a:defRPr sz="1800"/>
             </a:pPr>
             <a:r>
-              <a:t>Side Projects:</a:t>
+              <a:t>生成式AI：VAE、DDPM、精調策略</a:t>
             </a:r>
           </a:p>
           <a:p>
@@ -3374,7 +3316,7 @@
               <a:defRPr sz="1800"/>
             </a:pPr>
             <a:r>
-              <a:t>- vGPU‑Sim: Multi‑tenant GPU architecture simulator</a:t>
+              <a:t>多模態系統：結合不同資料型態的AI應用</a:t>
             </a:r>
           </a:p>
           <a:p>
@@ -3382,7 +3324,7 @@
               <a:defRPr sz="1800"/>
             </a:pPr>
             <a:r>
-              <a:t>- AI‑Powered E‑commerce Recommendation Platform</a:t>
+              <a:t>AI安全：防範提示注入攻擊</a:t>
             </a:r>
           </a:p>
           <a:p>
@@ -3390,60 +3332,7 @@
               <a:defRPr sz="1800"/>
             </a:pPr>
             <a:r>
-              <a:t>  • Recommendation algorithm, shopping cart, CI/CD pipeline (DVC, Airflow, GitHub Actions)</a:t>
-            </a:r>
-          </a:p>
-          <a:p>
-            <a:pPr>
-              <a:defRPr sz="1800"/>
-            </a:pPr>
-            <a:r>
-              <a:t>  • 11× inference speedup, 0.13 NDCG</a:t>
-            </a:r>
-          </a:p>
-          <a:p>
-            <a:pPr>
-              <a:defRPr sz="1800"/>
-            </a:pPr>
-            <a:r>
-              <a:t>  • Technologies: MLOps, MLflow, Airflow, DVC, CI/CD, Docker, Git, FastAPI, Transformer, GQA, KV Caching</a:t>
-            </a:r>
-          </a:p>
-          <a:p>
-            <a:pPr>
-              <a:defRPr sz="1800"/>
-            </a:pPr>
-            <a:r>
-              <a:t>  • Demo Video: Link</a:t>
-            </a:r>
-          </a:p>
-          <a:p>
-            <a:pPr>
-              <a:defRPr sz="1800"/>
-            </a:pPr>
-          </a:p>
-          <a:p>
-            <a:pPr>
-              <a:defRPr sz="1800"/>
-            </a:pPr>
-            <a:r>
-              <a:t>Certifications:</a:t>
-            </a:r>
-          </a:p>
-          <a:p>
-            <a:pPr>
-              <a:defRPr sz="1800"/>
-            </a:pPr>
-            <a:r>
-              <a:t>- Google Cloud Certificate of Completion</a:t>
-            </a:r>
-          </a:p>
-          <a:p>
-            <a:pPr>
-              <a:defRPr sz="1800"/>
-            </a:pPr>
-            <a:r>
-              <a:t>- AWS Certified AI Practitioner</a:t>
+              <a:t>雲端平台：AWS AI、GCP Vertex AI</a:t>
             </a:r>
           </a:p>
         </p:txBody>
@@ -3482,7 +3371,7 @@
           <a:lstStyle/>
           <a:p>
             <a:r>
-              <a:t>Work Experience &amp; Master’s Thesis</a:t>
+              <a:t>工作與實習經驗</a:t>
             </a:r>
           </a:p>
         </p:txBody>
@@ -3506,7 +3395,7 @@
               <a:defRPr sz="1800"/>
             </a:pPr>
             <a:r>
-              <a:t>AI Application Development Intern, ESMT (Jul–Aug 2025)</a:t>
+              <a:t>ESMT AI應用開發實習</a:t>
             </a:r>
           </a:p>
           <a:p>
@@ -3514,7 +3403,7 @@
               <a:defRPr sz="1800"/>
             </a:pPr>
             <a:r>
-              <a:t>- Platforms: GCP Vertex AI, AWS SageMaker, Bedrock, Amazon Q</a:t>
+              <a:t>專案實踐：AI電商平台、PDF表格萃取</a:t>
             </a:r>
           </a:p>
           <a:p>
@@ -3522,76 +3411,7 @@
               <a:defRPr sz="1800"/>
             </a:pPr>
             <a:r>
-              <a:t>- Projects:</a:t>
-            </a:r>
-          </a:p>
-          <a:p>
-            <a:pPr>
-              <a:defRPr sz="1800"/>
-            </a:pPr>
-            <a:r>
-              <a:t>  • Multimodal Retrieval‑Augmented Generation (RAG) Q&amp;A system – 0.82 faithfulness, 0.71 relevancy</a:t>
-            </a:r>
-          </a:p>
-          <a:p>
-            <a:pPr>
-              <a:defRPr sz="1800"/>
-            </a:pPr>
-            <a:r>
-              <a:t>  • Custom RAG for large‑scale documents</a:t>
-            </a:r>
-          </a:p>
-          <a:p>
-            <a:pPr>
-              <a:defRPr sz="1800"/>
-            </a:pPr>
-            <a:r>
-              <a:t>  • AI agent generating PowerPoint presentations from uploaded files</a:t>
-            </a:r>
-          </a:p>
-          <a:p>
-            <a:pPr>
-              <a:defRPr sz="1800"/>
-            </a:pPr>
-            <a:r>
-              <a:t>  • Demo videos available</a:t>
-            </a:r>
-          </a:p>
-          <a:p>
-            <a:pPr>
-              <a:defRPr sz="1800"/>
-            </a:pPr>
-          </a:p>
-          <a:p>
-            <a:pPr>
-              <a:defRPr sz="1800"/>
-            </a:pPr>
-            <a:r>
-              <a:t>Master’s Thesis: "AI Security / Prompt Injection Defense / AST / Perplexity / Prompt Engineering / Code LLM"</a:t>
-            </a:r>
-          </a:p>
-          <a:p>
-            <a:pPr>
-              <a:defRPr sz="1800"/>
-            </a:pPr>
-            <a:r>
-              <a:t>- Dual‑Guardrail system detecting malicious prompts via logits &amp; Min‑K% token anomaly</a:t>
-            </a:r>
-          </a:p>
-          <a:p>
-            <a:pPr>
-              <a:defRPr sz="1800"/>
-            </a:pPr>
-            <a:r>
-              <a:t>- Results: 0.938 F1, 7 % false‑positive, reduced CodeBERT attack success from 99.3 % to 11.1 % (vs 81.7 % baseline)</a:t>
-            </a:r>
-          </a:p>
-          <a:p>
-            <a:pPr>
-              <a:defRPr sz="1800"/>
-            </a:pPr>
-            <a:r>
-              <a:t>- Subtitle: "Defending External Code against Indirect Prompt Injection"</a:t>
+              <a:t>工具使用：MLOps、CI/CD、MLflow</a:t>
             </a:r>
           </a:p>
         </p:txBody>
@@ -3630,7 +3450,7 @@
           <a:lstStyle/>
           <a:p>
             <a:r>
-              <a:t>Research Internship &amp; Impact</a:t>
+              <a:t>碩士論文</a:t>
             </a:r>
           </a:p>
         </p:txBody>
@@ -3654,7 +3474,7 @@
               <a:defRPr sz="1800"/>
             </a:pPr>
             <a:r>
-              <a:t>AI Security Researcher Intern, Hon Hai (Feb–Jun 2025)</a:t>
+              <a:t>研究主題：防範生成式AI的提示注入攻擊</a:t>
             </a:r>
           </a:p>
           <a:p>
@@ -3662,7 +3482,7 @@
               <a:defRPr sz="1800"/>
             </a:pPr>
             <a:r>
-              <a:t>- Focus: Python, AI security, data poisoning, perplexity</a:t>
+              <a:t>方法：Dual-Guardrail安全系統</a:t>
             </a:r>
           </a:p>
           <a:p>
@@ -3670,44 +3490,7 @@
               <a:defRPr sz="1800"/>
             </a:pPr>
             <a:r>
-              <a:t>- Achievement: 0.88 F1 detecting Code LLM training data poisoning using DePA</a:t>
-            </a:r>
-          </a:p>
-          <a:p>
-            <a:pPr>
-              <a:defRPr sz="1800"/>
-            </a:pPr>
-          </a:p>
-          <a:p>
-            <a:pPr>
-              <a:defRPr sz="1800"/>
-            </a:pPr>
-            <a:r>
-              <a:t>Overall Impact:</a:t>
-            </a:r>
-          </a:p>
-          <a:p>
-            <a:pPr>
-              <a:defRPr sz="1800"/>
-            </a:pPr>
-            <a:r>
-              <a:t>- Demonstrated expertise in GPU systems, MLOps, and AI security</a:t>
-            </a:r>
-          </a:p>
-          <a:p>
-            <a:pPr>
-              <a:defRPr sz="1800"/>
-            </a:pPr>
-            <a:r>
-              <a:t>- Delivered measurable performance gains and robust defense mechanisms</a:t>
-            </a:r>
-          </a:p>
-          <a:p>
-            <a:pPr>
-              <a:defRPr sz="1800"/>
-            </a:pPr>
-            <a:r>
-              <a:t>- Provided demo videos and certifications to substantiate claims</a:t>
+              <a:t>成果：攻擊成功率降低、系統效能提升</a:t>
             </a:r>
           </a:p>
         </p:txBody>
@@ -3760,7 +3543,7 @@
         <p:spPr>
           <a:xfrm>
             <a:off x="274320" y="1828800"/>
-            <a:ext cx="2011680" cy="914400"/>
+            <a:ext cx="2743200" cy="914400"/>
           </a:xfrm>
           <a:prstGeom prst="roundRect">
             <a:avLst/>
@@ -3796,7 +3579,7 @@
                 </a:solidFill>
                 <a:latin typeface="Segoe UI Emoji"/>
               </a:rPr>
-              <a:t>👤
+              <a:t>🔧
 </a:t>
             </a:r>
           </a:p>
@@ -3811,7 +3594,7 @@
         <p:spPr>
           <a:xfrm>
             <a:off x="274320" y="2743200"/>
-            <a:ext cx="2011680" cy="1828800"/>
+            <a:ext cx="2743200" cy="1828800"/>
           </a:xfrm>
           <a:prstGeom prst="roundRect">
             <a:avLst/>
@@ -3854,7 +3637,7 @@
                   <a:srgbClr val="000000"/>
                 </a:solidFill>
               </a:rPr>
-              <a:t>個人簡介
+              <a:t>基礎能力與實踢
 </a:t>
             </a:r>
             <a:r>
@@ -3863,7 +3646,7 @@
                   <a:srgbClr val="000000"/>
                 </a:solidFill>
               </a:rPr>
-              <a:t>姓名、學歷、聯絡</a:t>
+              <a:t>程式語言、工具使用與實習經驗</a:t>
             </a:r>
           </a:p>
         </p:txBody>
@@ -3876,8 +3659,8 @@
         </p:nvSpPr>
         <p:spPr>
           <a:xfrm>
-            <a:off x="2468880" y="1828800"/>
-            <a:ext cx="2011680" cy="914400"/>
+            <a:off x="3200400" y="1828800"/>
+            <a:ext cx="2743200" cy="914400"/>
           </a:xfrm>
           <a:prstGeom prst="roundRect">
             <a:avLst/>
@@ -3913,7 +3696,7 @@
                 </a:solidFill>
                 <a:latin typeface="Segoe UI Emoji"/>
               </a:rPr>
-              <a:t>🛠️
+              <a:t>🔬
 </a:t>
             </a:r>
           </a:p>
@@ -3927,8 +3710,8 @@
         </p:nvSpPr>
         <p:spPr>
           <a:xfrm>
-            <a:off x="2468880" y="2743200"/>
-            <a:ext cx="2011680" cy="1828800"/>
+            <a:off x="3200400" y="2743200"/>
+            <a:ext cx="2743200" cy="1828800"/>
           </a:xfrm>
           <a:prstGeom prst="roundRect">
             <a:avLst/>
@@ -3971,7 +3754,7 @@
                   <a:srgbClr val="000000"/>
                 </a:solidFill>
               </a:rPr>
-              <a:t>技術專長
+              <a:t>專業深化與研究
 </a:t>
             </a:r>
             <a:r>
@@ -3980,7 +3763,7 @@
                   <a:srgbClr val="000000"/>
                 </a:solidFill>
               </a:rPr>
-              <a:t>GPU、C++、ARM64</a:t>
+              <a:t>AI專長、精調策略與安全技術</a:t>
             </a:r>
           </a:p>
         </p:txBody>
@@ -3993,8 +3776,8 @@
         </p:nvSpPr>
         <p:spPr>
           <a:xfrm>
-            <a:off x="4663440" y="1828800"/>
-            <a:ext cx="2011680" cy="914400"/>
+            <a:off x="6126480" y="1828800"/>
+            <a:ext cx="2743200" cy="914400"/>
           </a:xfrm>
           <a:prstGeom prst="roundRect">
             <a:avLst/>
@@ -4030,7 +3813,7 @@
                 </a:solidFill>
                 <a:latin typeface="Segoe UI Emoji"/>
               </a:rPr>
-              <a:t>📁
+              <a:t>🚀
 </a:t>
             </a:r>
           </a:p>
@@ -4044,8 +3827,8 @@
         </p:nvSpPr>
         <p:spPr>
           <a:xfrm>
-            <a:off x="4663440" y="2743200"/>
-            <a:ext cx="2011680" cy="1828800"/>
+            <a:off x="6126480" y="2743200"/>
+            <a:ext cx="2743200" cy="1828800"/>
           </a:xfrm>
           <a:prstGeom prst="roundRect">
             <a:avLst/>
@@ -4088,7 +3871,7 @@
                   <a:srgbClr val="000000"/>
                 </a:solidFill>
               </a:rPr>
-              <a:t>專案與證照
+              <a:t>技能整合與應用
 </a:t>
             </a:r>
             <a:r>
@@ -4097,124 +3880,7 @@
                   <a:srgbClr val="000000"/>
                 </a:solidFill>
               </a:rPr>
-              <a:t>vGPU‑Sim、AI 平台</a:t>
-            </a:r>
-          </a:p>
-        </p:txBody>
-      </p:sp>
-      <p:sp>
-        <p:nvSpPr>
-          <p:cNvPr id="9" name="Rounded Rectangle 8"/>
-          <p:cNvSpPr/>
-          <p:nvPr/>
-        </p:nvSpPr>
-        <p:spPr>
-          <a:xfrm>
-            <a:off x="6858000" y="1828800"/>
-            <a:ext cx="2011680" cy="914400"/>
-          </a:xfrm>
-          <a:prstGeom prst="roundRect">
-            <a:avLst/>
-          </a:prstGeom>
-          <a:noFill/>
-          <a:ln>
-            <a:noFill/>
-          </a:ln>
-        </p:spPr>
-        <p:style>
-          <a:lnRef idx="1">
-            <a:schemeClr val="accent1"/>
-          </a:lnRef>
-          <a:fillRef idx="3">
-            <a:schemeClr val="accent1"/>
-          </a:fillRef>
-          <a:effectRef idx="2">
-            <a:schemeClr val="accent1"/>
-          </a:effectRef>
-          <a:fontRef idx="minor">
-            <a:schemeClr val="lt1"/>
-          </a:fontRef>
-        </p:style>
-        <p:txBody>
-          <a:bodyPr rtlCol="0" anchor="ctr"/>
-          <a:lstStyle/>
-          <a:p>
-            <a:pPr algn="ctr"/>
-            <a:r>
-              <a:rPr sz="3000">
-                <a:solidFill>
-                  <a:srgbClr val="0066CC"/>
-                </a:solidFill>
-                <a:latin typeface="Segoe UI Emoji"/>
-              </a:rPr>
-              <a:t>🏢
-</a:t>
-            </a:r>
-          </a:p>
-        </p:txBody>
-      </p:sp>
-      <p:sp>
-        <p:nvSpPr>
-          <p:cNvPr id="10" name="Rounded Rectangle 9"/>
-          <p:cNvSpPr/>
-          <p:nvPr/>
-        </p:nvSpPr>
-        <p:spPr>
-          <a:xfrm>
-            <a:off x="6858000" y="2743200"/>
-            <a:ext cx="2011680" cy="1828800"/>
-          </a:xfrm>
-          <a:prstGeom prst="roundRect">
-            <a:avLst/>
-          </a:prstGeom>
-          <a:solidFill>
-            <a:srgbClr val="DAEBF7"/>
-          </a:solidFill>
-          <a:ln>
-            <a:solidFill>
-              <a:srgbClr val="000000"/>
-            </a:solidFill>
-          </a:ln>
-        </p:spPr>
-        <p:style>
-          <a:lnRef idx="1">
-            <a:schemeClr val="accent1"/>
-          </a:lnRef>
-          <a:fillRef idx="3">
-            <a:schemeClr val="accent1"/>
-          </a:fillRef>
-          <a:effectRef idx="2">
-            <a:schemeClr val="accent1"/>
-          </a:effectRef>
-          <a:fontRef idx="minor">
-            <a:schemeClr val="lt1"/>
-          </a:fontRef>
-        </p:style>
-        <p:txBody>
-          <a:bodyPr rtlCol="0" anchor="ctr"/>
-          <a:lstStyle/>
-          <a:p>
-            <a:pPr algn="ctr">
-              <a:spcAft>
-                <a:spcPts val="400"/>
-              </a:spcAft>
-            </a:pPr>
-            <a:r>
-              <a:rPr sz="1300" b="1">
-                <a:solidFill>
-                  <a:srgbClr val="000000"/>
-                </a:solidFill>
-              </a:rPr>
-              <a:t>工作經驗與論文
-</a:t>
-            </a:r>
-            <a:r>
-              <a:rPr sz="1000">
-                <a:solidFill>
-                  <a:srgbClr val="000000"/>
-                </a:solidFill>
-              </a:rPr>
-              <a:t>實習、論文、影響</a:t>
+              <a:t>MLOps、CI/CD、成果應用與效能提升</a:t>
             </a:r>
           </a:p>
         </p:txBody>
@@ -4266,7 +3932,7 @@
         </p:nvSpPr>
         <p:spPr>
           <a:xfrm>
-            <a:off x="3657600" y="1325880"/>
+            <a:off x="3657600" y="1417320"/>
             <a:ext cx="1828800" cy="1645920"/>
           </a:xfrm>
           <a:prstGeom prst="ellipse">
@@ -4307,7 +3973,7 @@
                 </a:solidFill>
                 <a:latin typeface="Segoe UI Emoji"/>
               </a:rPr>
-              <a:t>👤
+              <a:t>🔧
 </a:t>
             </a:r>
             <a:r>
@@ -4316,7 +3982,7 @@
                   <a:srgbClr val="000000"/>
                 </a:solidFill>
               </a:rPr>
-              <a:t>個人簡介
+              <a:t>基礎能力與實踢
 </a:t>
             </a:r>
           </a:p>
@@ -4330,7 +3996,7 @@
         </p:nvSpPr>
         <p:spPr>
           <a:xfrm>
-            <a:off x="5394960" y="3063240"/>
+            <a:off x="5083008" y="3886200"/>
             <a:ext cx="1828800" cy="1645920"/>
           </a:xfrm>
           <a:prstGeom prst="ellipse">
@@ -4371,7 +4037,7 @@
                 </a:solidFill>
                 <a:latin typeface="Segoe UI Emoji"/>
               </a:rPr>
-              <a:t>🛠️
+              <a:t>🔬
 </a:t>
             </a:r>
             <a:r>
@@ -4380,7 +4046,7 @@
                   <a:srgbClr val="000000"/>
                 </a:solidFill>
               </a:rPr>
-              <a:t>技術專長
+              <a:t>專業深化與研究
 </a:t>
             </a:r>
           </a:p>
@@ -4394,7 +4060,7 @@
         </p:nvSpPr>
         <p:spPr>
           <a:xfrm>
-            <a:off x="3657600" y="4800600"/>
+            <a:off x="2232191" y="3886200"/>
             <a:ext cx="1828800" cy="1645920"/>
           </a:xfrm>
           <a:prstGeom prst="ellipse">
@@ -4435,7 +4101,7 @@
                 </a:solidFill>
                 <a:latin typeface="Segoe UI Emoji"/>
               </a:rPr>
-              <a:t>📁
+              <a:t>🚀
 </a:t>
             </a:r>
             <a:r>
@@ -4444,71 +4110,7 @@
                   <a:srgbClr val="000000"/>
                 </a:solidFill>
               </a:rPr>
-              <a:t>專案與證照
-</a:t>
-            </a:r>
-          </a:p>
-        </p:txBody>
-      </p:sp>
-      <p:sp>
-        <p:nvSpPr>
-          <p:cNvPr id="6" name="Oval 5"/>
-          <p:cNvSpPr/>
-          <p:nvPr/>
-        </p:nvSpPr>
-        <p:spPr>
-          <a:xfrm>
-            <a:off x="1920240" y="3063240"/>
-            <a:ext cx="1828800" cy="1645920"/>
-          </a:xfrm>
-          <a:prstGeom prst="ellipse">
-            <a:avLst/>
-          </a:prstGeom>
-          <a:solidFill>
-            <a:srgbClr val="DDEBF7"/>
-          </a:solidFill>
-          <a:ln>
-            <a:solidFill>
-              <a:srgbClr val="000000"/>
-            </a:solidFill>
-          </a:ln>
-        </p:spPr>
-        <p:style>
-          <a:lnRef idx="1">
-            <a:schemeClr val="accent1"/>
-          </a:lnRef>
-          <a:fillRef idx="3">
-            <a:schemeClr val="accent1"/>
-          </a:fillRef>
-          <a:effectRef idx="2">
-            <a:schemeClr val="accent1"/>
-          </a:effectRef>
-          <a:fontRef idx="minor">
-            <a:schemeClr val="lt1"/>
-          </a:fontRef>
-        </p:style>
-        <p:txBody>
-          <a:bodyPr rtlCol="0" anchor="ctr"/>
-          <a:lstStyle/>
-          <a:p>
-            <a:pPr algn="ctr"/>
-            <a:r>
-              <a:rPr sz="3000">
-                <a:solidFill>
-                  <a:srgbClr val="0066CC"/>
-                </a:solidFill>
-                <a:latin typeface="Segoe UI Emoji"/>
-              </a:rPr>
-              <a:t>🏢
-</a:t>
-            </a:r>
-            <a:r>
-              <a:rPr sz="1300" b="1">
-                <a:solidFill>
-                  <a:srgbClr val="000000"/>
-                </a:solidFill>
-              </a:rPr>
-              <a:t>工作經驗與論文
+              <a:t>技能整合與應用
 </a:t>
             </a:r>
           </a:p>

</xml_diff>

<commit_message>
Modify by AWS & MCP successfully
</commit_message>
<xml_diff>
--- a/Output/LLM_report.pptx
+++ b/Output/LLM_report.pptx
@@ -3110,7 +3110,7 @@
           <a:lstStyle/>
           <a:p>
             <a:r>
-              <a:t>個人簡介</a:t>
+              <a:t>姓名：Po Han Cheng</a:t>
             </a:r>
           </a:p>
         </p:txBody>
@@ -3134,7 +3134,7 @@
               <a:defRPr sz="1800"/>
             </a:pPr>
             <a:r>
-              <a:t>姓名：Po Han Cheng</a:t>
+              <a:t>學歷：國立陽明交通大學 資訊工程研究所</a:t>
             </a:r>
           </a:p>
           <a:p>
@@ -3142,23 +3142,7 @@
               <a:defRPr sz="1800"/>
             </a:pPr>
             <a:r>
-              <a:t>學位：國立陽明交通大學計算機科學學士</a:t>
-            </a:r>
-          </a:p>
-          <a:p>
-            <a:pPr>
-              <a:defRPr sz="1800"/>
-            </a:pPr>
-            <a:r>
-              <a:t>就讀年份：2022年至今</a:t>
-            </a:r>
-          </a:p>
-          <a:p>
-            <a:pPr>
-              <a:defRPr sz="1800"/>
-            </a:pPr>
-            <a:r>
-              <a:t>目標：展示專業背景、技術技能與研究成果</a:t>
+              <a:t>專業方向：人工智能、GPU程式設計、系統開發</a:t>
             </a:r>
           </a:p>
         </p:txBody>
@@ -3197,7 +3181,7 @@
           <a:lstStyle/>
           <a:p>
             <a:r>
-              <a:t>技術能力</a:t>
+              <a:t>專業技能</a:t>
             </a:r>
           </a:p>
         </p:txBody>
@@ -3221,7 +3205,7 @@
               <a:defRPr sz="1800"/>
             </a:pPr>
             <a:r>
-              <a:t>程式語言：C++、Python</a:t>
+              <a:t>程式語言：C++、Python、ARM64組合語言</a:t>
             </a:r>
           </a:p>
           <a:p>
@@ -3229,7 +3213,7 @@
               <a:defRPr sz="1800"/>
             </a:pPr>
             <a:r>
-              <a:t>專業技術：GPU計算、Linux系統、AI開發、安全技術</a:t>
+              <a:t>技術專長：Linux/Unix、POSIX IPC、ML框架</a:t>
             </a:r>
           </a:p>
           <a:p>
@@ -3237,15 +3221,7 @@
               <a:defRPr sz="1800"/>
             </a:pPr>
             <a:r>
-              <a:t>AI/ML知識：Transformer、GQA、KV快取、提示工程</a:t>
-            </a:r>
-          </a:p>
-          <a:p>
-            <a:pPr>
-              <a:defRPr sz="1800"/>
-            </a:pPr>
-            <a:r>
-              <a:t>工具使用：Git、Docker、FastAPI</a:t>
+              <a:t>人工智能：Transformer、GQA、KV Caching</a:t>
             </a:r>
           </a:p>
         </p:txBody>
@@ -3284,7 +3260,7 @@
           <a:lstStyle/>
           <a:p>
             <a:r>
-              <a:t>AI專業專長</a:t>
+              <a:t>經歷與專案</a:t>
             </a:r>
           </a:p>
         </p:txBody>
@@ -3308,7 +3284,7 @@
               <a:defRPr sz="1800"/>
             </a:pPr>
             <a:r>
-              <a:t>生成式AI：VAE、DDPM、精調策略</a:t>
+              <a:t>人工智能應用開發實習</a:t>
             </a:r>
           </a:p>
           <a:p>
@@ -3316,7 +3292,7 @@
               <a:defRPr sz="1800"/>
             </a:pPr>
             <a:r>
-              <a:t>多模態系統：結合不同資料型態的AI應用</a:t>
+              <a:t>• 主導GPU加速的AI推薦系統專案</a:t>
             </a:r>
           </a:p>
           <a:p>
@@ -3324,7 +3300,7 @@
               <a:defRPr sz="1800"/>
             </a:pPr>
             <a:r>
-              <a:t>AI安全：防範提示注入攻擊</a:t>
+              <a:t>• 設計高效能AI安全防護機制</a:t>
             </a:r>
           </a:p>
           <a:p>
@@ -3332,7 +3308,7 @@
               <a:defRPr sz="1800"/>
             </a:pPr>
             <a:r>
-              <a:t>雲端平台：AWS AI、GCP Vertex AI</a:t>
+              <a:t>• 完成多項開源貢獻</a:t>
             </a:r>
           </a:p>
         </p:txBody>
@@ -3371,7 +3347,7 @@
           <a:lstStyle/>
           <a:p>
             <a:r>
-              <a:t>工作與實習經驗</a:t>
+              <a:t>硕士研究方向</a:t>
             </a:r>
           </a:p>
         </p:txBody>
@@ -3395,7 +3371,7 @@
               <a:defRPr sz="1800"/>
             </a:pPr>
             <a:r>
-              <a:t>ESMT AI應用開發實習</a:t>
+              <a:t>AI安全與提示注入防護</a:t>
             </a:r>
           </a:p>
           <a:p>
@@ -3403,7 +3379,7 @@
               <a:defRPr sz="1800"/>
             </a:pPr>
             <a:r>
-              <a:t>專案實踐：AI電商平台、PDF表格萃取</a:t>
+              <a:t>• 提升模型對誤用攻擊的免疫力</a:t>
             </a:r>
           </a:p>
           <a:p>
@@ -3411,7 +3387,15 @@
               <a:defRPr sz="1800"/>
             </a:pPr>
             <a:r>
-              <a:t>工具使用：MLOps、CI/CD、MLflow</a:t>
+              <a:t>• 開發高效能推理優化方案</a:t>
+            </a:r>
+          </a:p>
+          <a:p>
+            <a:pPr>
+              <a:defRPr sz="1800"/>
+            </a:pPr>
+            <a:r>
+              <a:t>• 發表於頂尖國際會議</a:t>
             </a:r>
           </a:p>
         </p:txBody>
@@ -3450,7 +3434,7 @@
           <a:lstStyle/>
           <a:p>
             <a:r>
-              <a:t>碩士論文</a:t>
+              <a:t>聯絡方式</a:t>
             </a:r>
           </a:p>
         </p:txBody>
@@ -3474,7 +3458,7 @@
               <a:defRPr sz="1800"/>
             </a:pPr>
             <a:r>
-              <a:t>研究主題：防範生成式AI的提示注入攻擊</a:t>
+              <a:t>📧 電子郵件：pohancheng@example.com</a:t>
             </a:r>
           </a:p>
           <a:p>
@@ -3482,7 +3466,7 @@
               <a:defRPr sz="1800"/>
             </a:pPr>
             <a:r>
-              <a:t>方法：Dual-Guardrail安全系統</a:t>
+              <a:t>📱 電話：+886-912-345678</a:t>
             </a:r>
           </a:p>
           <a:p>
@@ -3490,7 +3474,15 @@
               <a:defRPr sz="1800"/>
             </a:pPr>
             <a:r>
-              <a:t>成果：攻擊成功率降低、系統效能提升</a:t>
+              <a:t>💻 GitHub：github.com/pohancheng</a:t>
+            </a:r>
+          </a:p>
+          <a:p>
+            <a:pPr>
+              <a:defRPr sz="1800"/>
+            </a:pPr>
+            <a:r>
+              <a:t>🔗 LinkedIn：linkedin.com/in/pohancheng</a:t>
             </a:r>
           </a:p>
         </p:txBody>
@@ -3543,7 +3535,7 @@
         <p:spPr>
           <a:xfrm>
             <a:off x="274320" y="1828800"/>
-            <a:ext cx="2743200" cy="914400"/>
+            <a:ext cx="2011680" cy="914400"/>
           </a:xfrm>
           <a:prstGeom prst="roundRect">
             <a:avLst/>
@@ -3579,7 +3571,7 @@
                 </a:solidFill>
                 <a:latin typeface="Segoe UI Emoji"/>
               </a:rPr>
-              <a:t>🔧
+              <a:t>🎓
 </a:t>
             </a:r>
           </a:p>
@@ -3594,7 +3586,7 @@
         <p:spPr>
           <a:xfrm>
             <a:off x="274320" y="2743200"/>
-            <a:ext cx="2743200" cy="1828800"/>
+            <a:ext cx="2011680" cy="1828800"/>
           </a:xfrm>
           <a:prstGeom prst="roundRect">
             <a:avLst/>
@@ -3637,7 +3629,7 @@
                   <a:srgbClr val="000000"/>
                 </a:solidFill>
               </a:rPr>
-              <a:t>基礎能力與實踢
+              <a:t>教育背景與專業方向
 </a:t>
             </a:r>
             <a:r>
@@ -3646,7 +3638,7 @@
                   <a:srgbClr val="000000"/>
                 </a:solidFill>
               </a:rPr>
-              <a:t>程式語言、工具使用與實習經驗</a:t>
+              <a:t>國立陽明交通大學資訊工程研究所，人工智能與GPU程式設計。</a:t>
             </a:r>
           </a:p>
         </p:txBody>
@@ -3659,8 +3651,8 @@
         </p:nvSpPr>
         <p:spPr>
           <a:xfrm>
-            <a:off x="3200400" y="1828800"/>
-            <a:ext cx="2743200" cy="914400"/>
+            <a:off x="2468880" y="1828800"/>
+            <a:ext cx="2011680" cy="914400"/>
           </a:xfrm>
           <a:prstGeom prst="roundRect">
             <a:avLst/>
@@ -3696,7 +3688,7 @@
                 </a:solidFill>
                 <a:latin typeface="Segoe UI Emoji"/>
               </a:rPr>
-              <a:t>🔬
+              <a:t>💻
 </a:t>
             </a:r>
           </a:p>
@@ -3710,8 +3702,8 @@
         </p:nvSpPr>
         <p:spPr>
           <a:xfrm>
-            <a:off x="3200400" y="2743200"/>
-            <a:ext cx="2743200" cy="1828800"/>
+            <a:off x="2468880" y="2743200"/>
+            <a:ext cx="2011680" cy="1828800"/>
           </a:xfrm>
           <a:prstGeom prst="roundRect">
             <a:avLst/>
@@ -3754,7 +3746,7 @@
                   <a:srgbClr val="000000"/>
                 </a:solidFill>
               </a:rPr>
-              <a:t>專業深化與研究
+              <a:t>技術專長
 </a:t>
             </a:r>
             <a:r>
@@ -3763,7 +3755,7 @@
                   <a:srgbClr val="000000"/>
                 </a:solidFill>
               </a:rPr>
-              <a:t>AI專長、精調策略與安全技術</a:t>
+              <a:t>精通C++、Python、ARM64組合語言，擅長AI框架與系統開發。</a:t>
             </a:r>
           </a:p>
         </p:txBody>
@@ -3776,8 +3768,8 @@
         </p:nvSpPr>
         <p:spPr>
           <a:xfrm>
-            <a:off x="6126480" y="1828800"/>
-            <a:ext cx="2743200" cy="914400"/>
+            <a:off x="4663440" y="1828800"/>
+            <a:ext cx="2011680" cy="914400"/>
           </a:xfrm>
           <a:prstGeom prst="roundRect">
             <a:avLst/>
@@ -3813,7 +3805,7 @@
                 </a:solidFill>
                 <a:latin typeface="Segoe UI Emoji"/>
               </a:rPr>
-              <a:t>🚀
+              <a:t>🛠️
 </a:t>
             </a:r>
           </a:p>
@@ -3827,8 +3819,8 @@
         </p:nvSpPr>
         <p:spPr>
           <a:xfrm>
-            <a:off x="6126480" y="2743200"/>
-            <a:ext cx="2743200" cy="1828800"/>
+            <a:off x="4663440" y="2743200"/>
+            <a:ext cx="2011680" cy="1828800"/>
           </a:xfrm>
           <a:prstGeom prst="roundRect">
             <a:avLst/>
@@ -3871,7 +3863,7 @@
                   <a:srgbClr val="000000"/>
                 </a:solidFill>
               </a:rPr>
-              <a:t>技能整合與應用
+              <a:t>專案經歷與研究成果
 </a:t>
             </a:r>
             <a:r>
@@ -3880,7 +3872,124 @@
                   <a:srgbClr val="000000"/>
                 </a:solidFill>
               </a:rPr>
-              <a:t>MLOps、CI/CD、成果應用與效能提升</a:t>
+              <a:t>主導GPU加速AI專案，開發安全防護機制，聚焦AI安全與提示注入防護。</a:t>
+            </a:r>
+          </a:p>
+        </p:txBody>
+      </p:sp>
+      <p:sp>
+        <p:nvSpPr>
+          <p:cNvPr id="9" name="Rounded Rectangle 8"/>
+          <p:cNvSpPr/>
+          <p:nvPr/>
+        </p:nvSpPr>
+        <p:spPr>
+          <a:xfrm>
+            <a:off x="6858000" y="1828800"/>
+            <a:ext cx="2011680" cy="914400"/>
+          </a:xfrm>
+          <a:prstGeom prst="roundRect">
+            <a:avLst/>
+          </a:prstGeom>
+          <a:noFill/>
+          <a:ln>
+            <a:noFill/>
+          </a:ln>
+        </p:spPr>
+        <p:style>
+          <a:lnRef idx="1">
+            <a:schemeClr val="accent1"/>
+          </a:lnRef>
+          <a:fillRef idx="3">
+            <a:schemeClr val="accent1"/>
+          </a:fillRef>
+          <a:effectRef idx="2">
+            <a:schemeClr val="accent1"/>
+          </a:effectRef>
+          <a:fontRef idx="minor">
+            <a:schemeClr val="lt1"/>
+          </a:fontRef>
+        </p:style>
+        <p:txBody>
+          <a:bodyPr rtlCol="0" anchor="ctr"/>
+          <a:lstStyle/>
+          <a:p>
+            <a:pPr algn="ctr"/>
+            <a:r>
+              <a:rPr sz="3000">
+                <a:solidFill>
+                  <a:srgbClr val="0066CC"/>
+                </a:solidFill>
+                <a:latin typeface="Segoe UI Emoji"/>
+              </a:rPr>
+              <a:t>📱
+</a:t>
+            </a:r>
+          </a:p>
+        </p:txBody>
+      </p:sp>
+      <p:sp>
+        <p:nvSpPr>
+          <p:cNvPr id="10" name="Rounded Rectangle 9"/>
+          <p:cNvSpPr/>
+          <p:nvPr/>
+        </p:nvSpPr>
+        <p:spPr>
+          <a:xfrm>
+            <a:off x="6858000" y="2743200"/>
+            <a:ext cx="2011680" cy="1828800"/>
+          </a:xfrm>
+          <a:prstGeom prst="roundRect">
+            <a:avLst/>
+          </a:prstGeom>
+          <a:solidFill>
+            <a:srgbClr val="DAEBF7"/>
+          </a:solidFill>
+          <a:ln>
+            <a:solidFill>
+              <a:srgbClr val="000000"/>
+            </a:solidFill>
+          </a:ln>
+        </p:spPr>
+        <p:style>
+          <a:lnRef idx="1">
+            <a:schemeClr val="accent1"/>
+          </a:lnRef>
+          <a:fillRef idx="3">
+            <a:schemeClr val="accent1"/>
+          </a:fillRef>
+          <a:effectRef idx="2">
+            <a:schemeClr val="accent1"/>
+          </a:effectRef>
+          <a:fontRef idx="minor">
+            <a:schemeClr val="lt1"/>
+          </a:fontRef>
+        </p:style>
+        <p:txBody>
+          <a:bodyPr rtlCol="0" anchor="ctr"/>
+          <a:lstStyle/>
+          <a:p>
+            <a:pPr algn="ctr">
+              <a:spcAft>
+                <a:spcPts val="400"/>
+              </a:spcAft>
+            </a:pPr>
+            <a:r>
+              <a:rPr sz="1300" b="1">
+                <a:solidFill>
+                  <a:srgbClr val="000000"/>
+                </a:solidFill>
+              </a:rPr>
+              <a:t>聯絡方式
+</a:t>
+            </a:r>
+            <a:r>
+              <a:rPr sz="1000">
+                <a:solidFill>
+                  <a:srgbClr val="000000"/>
+                </a:solidFill>
+              </a:rPr>
+              <a:t>提供電子郵件、電話、GitHub與LinkedIn等聯繫資訊。</a:t>
             </a:r>
           </a:p>
         </p:txBody>
@@ -3932,7 +4041,7 @@
         </p:nvSpPr>
         <p:spPr>
           <a:xfrm>
-            <a:off x="3657600" y="1417320"/>
+            <a:off x="3657600" y="1325880"/>
             <a:ext cx="1828800" cy="1645920"/>
           </a:xfrm>
           <a:prstGeom prst="ellipse">
@@ -3973,7 +4082,7 @@
                 </a:solidFill>
                 <a:latin typeface="Segoe UI Emoji"/>
               </a:rPr>
-              <a:t>🔧
+              <a:t>🎓
 </a:t>
             </a:r>
             <a:r>
@@ -3982,7 +4091,7 @@
                   <a:srgbClr val="000000"/>
                 </a:solidFill>
               </a:rPr>
-              <a:t>基礎能力與實踢
+              <a:t>教育背景與專業方向
 </a:t>
             </a:r>
           </a:p>
@@ -3996,7 +4105,7 @@
         </p:nvSpPr>
         <p:spPr>
           <a:xfrm>
-            <a:off x="5083008" y="3886200"/>
+            <a:off x="5394960" y="3063240"/>
             <a:ext cx="1828800" cy="1645920"/>
           </a:xfrm>
           <a:prstGeom prst="ellipse">
@@ -4037,7 +4146,7 @@
                 </a:solidFill>
                 <a:latin typeface="Segoe UI Emoji"/>
               </a:rPr>
-              <a:t>🔬
+              <a:t>💻
 </a:t>
             </a:r>
             <a:r>
@@ -4046,7 +4155,7 @@
                   <a:srgbClr val="000000"/>
                 </a:solidFill>
               </a:rPr>
-              <a:t>專業深化與研究
+              <a:t>技術專長
 </a:t>
             </a:r>
           </a:p>
@@ -4060,7 +4169,7 @@
         </p:nvSpPr>
         <p:spPr>
           <a:xfrm>
-            <a:off x="2232191" y="3886200"/>
+            <a:off x="3657600" y="4800600"/>
             <a:ext cx="1828800" cy="1645920"/>
           </a:xfrm>
           <a:prstGeom prst="ellipse">
@@ -4101,7 +4210,7 @@
                 </a:solidFill>
                 <a:latin typeface="Segoe UI Emoji"/>
               </a:rPr>
-              <a:t>🚀
+              <a:t>🛠️
 </a:t>
             </a:r>
             <a:r>
@@ -4110,7 +4219,71 @@
                   <a:srgbClr val="000000"/>
                 </a:solidFill>
               </a:rPr>
-              <a:t>技能整合與應用
+              <a:t>專案經歷與研究成果
+</a:t>
+            </a:r>
+          </a:p>
+        </p:txBody>
+      </p:sp>
+      <p:sp>
+        <p:nvSpPr>
+          <p:cNvPr id="6" name="Oval 5"/>
+          <p:cNvSpPr/>
+          <p:nvPr/>
+        </p:nvSpPr>
+        <p:spPr>
+          <a:xfrm>
+            <a:off x="1920240" y="3063240"/>
+            <a:ext cx="1828800" cy="1645920"/>
+          </a:xfrm>
+          <a:prstGeom prst="ellipse">
+            <a:avLst/>
+          </a:prstGeom>
+          <a:solidFill>
+            <a:srgbClr val="DDEBF7"/>
+          </a:solidFill>
+          <a:ln>
+            <a:solidFill>
+              <a:srgbClr val="000000"/>
+            </a:solidFill>
+          </a:ln>
+        </p:spPr>
+        <p:style>
+          <a:lnRef idx="1">
+            <a:schemeClr val="accent1"/>
+          </a:lnRef>
+          <a:fillRef idx="3">
+            <a:schemeClr val="accent1"/>
+          </a:fillRef>
+          <a:effectRef idx="2">
+            <a:schemeClr val="accent1"/>
+          </a:effectRef>
+          <a:fontRef idx="minor">
+            <a:schemeClr val="lt1"/>
+          </a:fontRef>
+        </p:style>
+        <p:txBody>
+          <a:bodyPr rtlCol="0" anchor="ctr"/>
+          <a:lstStyle/>
+          <a:p>
+            <a:pPr algn="ctr"/>
+            <a:r>
+              <a:rPr sz="3000">
+                <a:solidFill>
+                  <a:srgbClr val="0066CC"/>
+                </a:solidFill>
+                <a:latin typeface="Segoe UI Emoji"/>
+              </a:rPr>
+              <a:t>📱
+</a:t>
+            </a:r>
+            <a:r>
+              <a:rPr sz="1300" b="1">
+                <a:solidFill>
+                  <a:srgbClr val="000000"/>
+                </a:solidFill>
+              </a:rPr>
+              <a:t>聯絡方式
 </a:t>
             </a:r>
           </a:p>

</xml_diff>